<commit_message>
fix(frontend): polish deliverable template samples
</commit_message>
<xml_diff>
--- a/design/samples/board-deck-sample.pptx
+++ b/design/samples/board-deck-sample.pptx
@@ -4610,7 +4610,7 @@
         <p:spPr>
           <a:xfrm>
             <a:off x="822960" y="3246120"/>
-            <a:ext cx="1243584" cy="256032"/>
+            <a:ext cx="1682496" cy="256032"/>
           </a:xfrm>
           <a:prstGeom prst="roundRect">
             <a:avLst>
@@ -4637,7 +4637,7 @@
         <p:spPr>
           <a:xfrm>
             <a:off x="822960" y="3246120"/>
-            <a:ext cx="1243584" cy="256032"/>
+            <a:ext cx="1682496" cy="256032"/>
           </a:xfrm>
           <a:prstGeom prst="rect">
             <a:avLst/>
@@ -4678,7 +4678,7 @@
         <p:spPr>
           <a:xfrm>
             <a:off x="2286000" y="3246120"/>
-            <a:ext cx="1106424" cy="256032"/>
+            <a:ext cx="1508760" cy="256032"/>
           </a:xfrm>
           <a:prstGeom prst="roundRect">
             <a:avLst>
@@ -4705,7 +4705,7 @@
         <p:spPr>
           <a:xfrm>
             <a:off x="2286000" y="3246120"/>
-            <a:ext cx="1106424" cy="256032"/>
+            <a:ext cx="1508760" cy="256032"/>
           </a:xfrm>
           <a:prstGeom prst="rect">
             <a:avLst/>
@@ -5453,7 +5453,7 @@
         <p:spPr>
           <a:xfrm>
             <a:off x="9784080" y="1929384"/>
-            <a:ext cx="1243584" cy="256032"/>
+            <a:ext cx="1682496" cy="256032"/>
           </a:xfrm>
           <a:prstGeom prst="roundRect">
             <a:avLst>
@@ -5480,7 +5480,7 @@
         <p:spPr>
           <a:xfrm>
             <a:off x="9784080" y="1929384"/>
-            <a:ext cx="1243584" cy="256032"/>
+            <a:ext cx="1682496" cy="256032"/>
           </a:xfrm>
           <a:prstGeom prst="rect">
             <a:avLst/>
@@ -5655,7 +5655,7 @@
         <p:spPr>
           <a:xfrm>
             <a:off x="9784080" y="2962656"/>
-            <a:ext cx="626364" cy="256032"/>
+            <a:ext cx="1143000" cy="256032"/>
           </a:xfrm>
           <a:prstGeom prst="roundRect">
             <a:avLst>
@@ -5682,7 +5682,7 @@
         <p:spPr>
           <a:xfrm>
             <a:off x="9784080" y="2962656"/>
-            <a:ext cx="626364" cy="256032"/>
+            <a:ext cx="1143000" cy="256032"/>
           </a:xfrm>
           <a:prstGeom prst="rect">
             <a:avLst/>
@@ -5857,7 +5857,7 @@
         <p:spPr>
           <a:xfrm>
             <a:off x="9784080" y="3995928"/>
-            <a:ext cx="557784" cy="256032"/>
+            <a:ext cx="1143000" cy="256032"/>
           </a:xfrm>
           <a:prstGeom prst="roundRect">
             <a:avLst>
@@ -5884,7 +5884,7 @@
         <p:spPr>
           <a:xfrm>
             <a:off x="9784080" y="3995928"/>
-            <a:ext cx="557784" cy="256032"/>
+            <a:ext cx="1143000" cy="256032"/>
           </a:xfrm>
           <a:prstGeom prst="rect">
             <a:avLst/>
@@ -6059,7 +6059,7 @@
         <p:spPr>
           <a:xfrm>
             <a:off x="9784080" y="5029200"/>
-            <a:ext cx="557784" cy="256032"/>
+            <a:ext cx="1143000" cy="256032"/>
           </a:xfrm>
           <a:prstGeom prst="roundRect">
             <a:avLst>
@@ -6086,7 +6086,7 @@
         <p:spPr>
           <a:xfrm>
             <a:off x="9784080" y="5029200"/>
-            <a:ext cx="557784" cy="256032"/>
+            <a:ext cx="1143000" cy="256032"/>
           </a:xfrm>
           <a:prstGeom prst="rect">
             <a:avLst/>

</xml_diff>